<commit_message>
fix typo in PP
</commit_message>
<xml_diff>
--- a/reports/PR2025-26_VMESNA_08.pptx
+++ b/reports/PR2025-26_VMESNA_08.pptx
@@ -5525,15 +5525,23 @@
           <a:p>
             <a:r>
               <a:rPr lang="sl-SI" sz="1600" dirty="0"/>
-              <a:t>Izrazito največ oglasov v osrednjeslovenski regiji (1915), sledita ji </a:t>
-            </a:r>
-            <a:r>
-              <a:rPr lang="sl-SI" sz="1600" dirty="0" err="1"/>
-              <a:t>Gorenska</a:t>
+              <a:t>Izrazito največ oglasov v osrednjeslovenski regiji (1915), sledita </a:t>
+            </a:r>
+            <a:r>
+              <a:rPr lang="sl-SI" sz="1600"/>
+              <a:t>ji gorenjska </a:t>
             </a:r>
             <a:r>
               <a:rPr lang="sl-SI" sz="1600" dirty="0"/>
-              <a:t> (481) in Podravska (455)</a:t>
+              <a:t>(481) </a:t>
+            </a:r>
+            <a:r>
+              <a:rPr lang="sl-SI" sz="1600"/>
+              <a:t>in podravska </a:t>
+            </a:r>
+            <a:r>
+              <a:rPr lang="sl-SI" sz="1600" dirty="0"/>
+              <a:t>(455)</a:t>
             </a:r>
           </a:p>
           <a:p>

</xml_diff>